<commit_message>
Fix: properly register all 10 slides in presentation.xml
</commit_message>
<xml_diff>
--- a/青少年心理健康系统汇报.pptx
+++ b/青少年心理健康系统汇报.pptx
@@ -5,8 +5,16 @@
     <p:sldMasterId id="2147483648" r:id="rId1"/>
   </p:sldMasterIdLst>
   <p:sldIdLst>
-    <p:sldId id="256" r:id="rId2"/>
-    <p:sldId id="257" r:id="rId3"/>
+    <p:sldId id="257" r:id="rId5"/>
+    <p:sldId id="258" r:id="rId6"/>
+    <p:sldId id="259" r:id="rId7"/>
+    <p:sldId id="260" r:id="rId8"/>
+    <p:sldId id="261" r:id="rId9"/>
+    <p:sldId id="262" r:id="rId10"/>
+    <p:sldId id="263" r:id="rId11"/>
+    <p:sldId id="264" r:id="rId12"/>
+    <p:sldId id="265" r:id="rId13"/>
+    <p:sldId id="266" r:id="rId14"/>
   </p:sldIdLst>
   <p:notesMasterIdLst>
     <p:notesMasterId r:id="rId4"/>

</xml_diff>

<commit_message>
Fix: include all 10 slides in presentation.xml
</commit_message>
<xml_diff>
--- a/青少年心理健康系统汇报.pptx
+++ b/青少年心理健康系统汇报.pptx
@@ -5,16 +5,16 @@
     <p:sldMasterId id="2147483648" r:id="rId1"/>
   </p:sldMasterIdLst>
   <p:sldIdLst>
-    <p:sldId id="257" r:id="rId5"/>
-    <p:sldId id="258" r:id="rId6"/>
-    <p:sldId id="259" r:id="rId7"/>
-    <p:sldId id="260" r:id="rId8"/>
-    <p:sldId id="261" r:id="rId9"/>
-    <p:sldId id="262" r:id="rId10"/>
-    <p:sldId id="263" r:id="rId11"/>
-    <p:sldId id="264" r:id="rId12"/>
-    <p:sldId id="265" r:id="rId13"/>
-    <p:sldId id="266" r:id="rId14"/>
+    <p:sldId id="256" r:id="rId2"/>
+    <p:sldId id="257" r:id="rId3"/>
+    <p:sldId id="258" r:id="rId4"/>
+    <p:sldId id="259" r:id="rId5"/>
+    <p:sldId id="260" r:id="rId6"/>
+    <p:sldId id="261" r:id="rId7"/>
+    <p:sldId id="262" r:id="rId8"/>
+    <p:sldId id="263" r:id="rId9"/>
+    <p:sldId id="264" r:id="rId10"/>
+    <p:sldId id="265" r:id="rId11"/>
   </p:sldIdLst>
   <p:notesMasterIdLst>
     <p:notesMasterId r:id="rId4"/>

</xml_diff>